<commit_message>
Tighten 0909 Progress Report copy so slide text stays inside the frame.
Shorten long bullets on the technical and programme slides, merge the
vent-height note into the cabinet line, and add space above the open-item
card so it no longer covers the last layout point.

Co-authored-by: peterli0913 <peterli0913@users.noreply.github.com>
</commit_message>
<xml_diff>
--- a/Progress_Report_0909.pptx
+++ b/Progress_Report_0909.pptx
@@ -3435,7 +3435,7 @@
                 <a:latin typeface="Segoe UI"/>
                 <a:ea typeface="Microsoft YaHei"/>
               </a:rPr>
-              <a:t>PIC-028 remains Bronkhorst, provided the mechanical seal does not leak at the 270 °C relief case</a:t>
+              <a:t>PIC-028 stays Bronkhorst if the mechanical seal holds at 270 °C</a:t>
             </a:r>
           </a:p>
           <a:p>
@@ -3447,7 +3447,7 @@
                 <a:latin typeface="Microsoft YaHei"/>
                 <a:ea typeface="Microsoft YaHei"/>
               </a:rPr>
-              <a:t>             PIC-028 继续用 Bronkhorst，前提是 270 ℃ 泄放时机械密封不外漏</a:t>
+              <a:t>             PIC-028 继续用 Bronkhorst，前提是 270 ℃ 时机械密封不外漏</a:t>
             </a:r>
           </a:p>
         </p:txBody>
@@ -3536,7 +3536,7 @@
                 <a:latin typeface="Segoe UI"/>
                 <a:ea typeface="Microsoft YaHei"/>
               </a:rPr>
-              <a:t>Compact split-skid, 2.5 m shipping height, withdrawable front module rather than a centre aisle</a:t>
+              <a:t>Compact split-skid, 2.5 m shipping height, withdrawable front module</a:t>
             </a:r>
           </a:p>
           <a:p>
@@ -3548,7 +3548,7 @@
                 <a:latin typeface="Microsoft YaHei"/>
                 <a:ea typeface="Microsoft YaHei"/>
               </a:rPr>
-              <a:t>             紧凑分撬、运输高度 2.5 m、前撬可拉出，不再留中间通道</a:t>
+              <a:t>             紧凑分撬、运输高度 2.5 m、前撬可拉出，不留中间通道</a:t>
             </a:r>
           </a:p>
         </p:txBody>
@@ -3699,7 +3699,7 @@
                 <a:latin typeface="Segoe UI"/>
                 <a:ea typeface="Microsoft YaHei"/>
               </a:rPr>
-              <a:t>Site walkdown · 3D model · operating manual / control / sequence · HAZOP — dates for confirmation with Keith and Claire</a:t>
+              <a:t>Walkdown, 3D, manuals / control / sequence, then HAZOP — dates for Keith and Claire to confirm</a:t>
             </a:r>
           </a:p>
           <a:p>
@@ -3711,7 +3711,7 @@
                 <a:latin typeface="Microsoft YaHei"/>
                 <a:ea typeface="Microsoft YaHei"/>
               </a:rPr>
-              <a:t>             现场勘察 · 3D 模型 · 操作手册 / 控制说明 / 顺控 · HAZOP——日期待与 Keith、Claire 确认</a:t>
+              <a:t>             勘察、3D、手册 / 控制 / 顺控，然后 HAZOP——日期待 Keith、Claire 确认</a:t>
             </a:r>
           </a:p>
         </p:txBody>
@@ -4166,7 +4166,7 @@
                 <a:latin typeface="Segoe UI"/>
                 <a:ea typeface="Microsoft YaHei"/>
               </a:rPr>
-              <a:t>PIC-028 — closed.  Electronics may fail in a 270 °C relief event; the seal must not</a:t>
+              <a:t>PIC-028 — closed.  Electronics may fail at 270 °C; the seal must not</a:t>
             </a:r>
           </a:p>
           <a:p>
@@ -4183,7 +4183,7 @@
                 <a:latin typeface="Microsoft YaHei"/>
                 <a:ea typeface="Microsoft YaHei"/>
               </a:rPr>
-              <a:t>     PIC-028 已关闭：270 ℃ 泄放时电子件允许失效，密封不得外漏</a:t>
+              <a:t>     PIC-028 已关闭：270 ℃ 时电子件允许失效，密封不得外漏</a:t>
             </a:r>
           </a:p>
           <a:p>
@@ -4210,7 +4210,7 @@
                 <a:latin typeface="Segoe UI"/>
                 <a:ea typeface="Microsoft YaHei"/>
               </a:rPr>
-              <a:t>Relief remains on the PSV; the valve is replaced afterwards.  Seal material is FFKM, to be on the datasheet and the order.  The same check applies to FCV-004 if needed</a:t>
+              <a:t>PSV takes the relief; valve is replaced afterwards.  FFKM on the datasheet and the order; same check for FCV-004 if needed</a:t>
             </a:r>
           </a:p>
           <a:p>
@@ -4222,7 +4222,7 @@
                 <a:latin typeface="Microsoft YaHei"/>
                 <a:ea typeface="Microsoft YaHei"/>
               </a:rPr>
-              <a:t>             泄放仍由安全阀承担，事后换阀。密封材质 FFKM，须写入数据单与合同；FCV-004 视情况同样处理</a:t>
+              <a:t>             泄放由安全阀承担，事后换阀。FFKM 写入数据单与合同；FCV-004 视情况同样处理</a:t>
             </a:r>
           </a:p>
         </p:txBody>
@@ -4236,7 +4236,7 @@
         <p:spPr>
           <a:xfrm>
             <a:off x="640080" y="3291840"/>
-            <a:ext cx="10972800" cy="1719072"/>
+            <a:ext cx="10972800" cy="1408176"/>
           </a:xfrm>
           <a:prstGeom prst="rect">
             <a:avLst/>
@@ -4311,7 +4311,7 @@
                 <a:latin typeface="Segoe UI"/>
                 <a:ea typeface="Microsoft YaHei"/>
               </a:rPr>
-              <a:t>Ten TCU pipes through a wall plate — China supplies the plate, UK cuts the slot; last elbow fitted on site</a:t>
+              <a:t>Ten TCU pipes through a wall plate (China plate / UK slot); last elbow fitted on site</a:t>
             </a:r>
           </a:p>
           <a:p>
@@ -4323,7 +4323,7 @@
                 <a:latin typeface="Microsoft YaHei"/>
                 <a:ea typeface="Microsoft YaHei"/>
               </a:rPr>
-              <a:t>             10 根 TCU 管经穿墙板：中方出板、英方开槽；最后弯头现场安装</a:t>
+              <a:t>             10 根 TCU 管经穿墙板（中方出板、英方开槽）；最后弯头现场安装</a:t>
             </a:r>
           </a:p>
           <a:p>
@@ -4350,7 +4350,7 @@
                 <a:latin typeface="Segoe UI"/>
                 <a:ea typeface="Microsoft YaHei"/>
               </a:rPr>
-              <a:t>Separator may be lowered after the CIP change; new height goes to process for residual pressure after letdown</a:t>
+              <a:t>Separator may be lowered after the CIP change; new height goes to process</a:t>
             </a:r>
           </a:p>
           <a:p>
@@ -4389,7 +4389,7 @@
                 <a:latin typeface="Segoe UI"/>
                 <a:ea typeface="Microsoft YaHei"/>
               </a:rPr>
-              <a:t>Control cabinet moved back and made rectangular so it can be reached; envelope to be sent to Keith for enquiry</a:t>
+              <a:t>Cabinet set back and rectangular; vents over 2.5 m stripped for shipping</a:t>
             </a:r>
           </a:p>
           <a:p>
@@ -4401,46 +4401,7 @@
                 <a:latin typeface="Microsoft YaHei"/>
                 <a:ea typeface="Microsoft YaHei"/>
               </a:rPr>
-              <a:t>             控制柜后移并改为长方形以便够到，目标外形尺寸发给 Keith 询价</a:t>
-            </a:r>
-          </a:p>
-          <a:p>
-            <a:pPr>
-              <a:spcBef>
-                <a:spcPts val="300"/>
-              </a:spcBef>
-            </a:pPr>
-            <a:r>
-              <a:rPr sz="1200" b="0" i="0">
-                <a:solidFill>
-                  <a:srgbClr val="B7C0CF"/>
-                </a:solidFill>
-                <a:latin typeface="Segoe UI"/>
-                <a:ea typeface="Microsoft YaHei"/>
-              </a:rPr>
-              <a:t>        –  </a:t>
-            </a:r>
-            <a:r>
-              <a:rPr sz="1300" b="0" i="0">
-                <a:solidFill>
-                  <a:srgbClr val="3C4A5A"/>
-                </a:solidFill>
-                <a:latin typeface="Segoe UI"/>
-                <a:ea typeface="Microsoft YaHei"/>
-              </a:rPr>
-              <a:t>Vents above 2.5 m are prefabricated, stripped for transport and restored on site</a:t>
-            </a:r>
-          </a:p>
-          <a:p>
-            <a:r>
-              <a:rPr sz="1000" b="0" i="0">
-                <a:solidFill>
-                  <a:srgbClr val="8A97AB"/>
-                </a:solidFill>
-                <a:latin typeface="Microsoft YaHei"/>
-                <a:ea typeface="Microsoft YaHei"/>
-              </a:rPr>
-              <a:t>             超过 2.5 m 的放散管国内预制，运输拆下、现场复原</a:t>
+              <a:t>             控制柜后移并改为长方形；超 2.5 m 放散管运输拆下、现场复原</a:t>
             </a:r>
           </a:p>
         </p:txBody>
@@ -4453,8 +4414,8 @@
         </p:nvSpPr>
         <p:spPr>
           <a:xfrm>
-            <a:off x="548640" y="4974336"/>
-            <a:ext cx="11091672" cy="1078992"/>
+            <a:off x="548640" y="4809744"/>
+            <a:ext cx="11091672" cy="1024128"/>
           </a:xfrm>
           <a:prstGeom prst="roundRect">
             <a:avLst/>
@@ -4499,8 +4460,8 @@
         </p:nvSpPr>
         <p:spPr>
           <a:xfrm>
-            <a:off x="777240" y="5065776"/>
-            <a:ext cx="10652760" cy="914400"/>
+            <a:off x="777240" y="4901183"/>
+            <a:ext cx="10652760" cy="859536"/>
           </a:xfrm>
           <a:prstGeom prst="rect">
             <a:avLst/>
@@ -5107,7 +5068,7 @@
                 <a:latin typeface="Segoe UI"/>
                 <a:ea typeface="Microsoft YaHei"/>
               </a:rPr>
-              <a:t>Draft FDS / SDS / HDS, control description and operating instructions issued as HAZOP input.  Finals after FAT.</a:t>
+              <a:t>Draft FDS / SDS / HDS, control description and operating instructions as HAZOP input.  Finals after FAT.</a:t>
             </a:r>
           </a:p>
           <a:p>
@@ -5293,7 +5254,7 @@
                 <a:latin typeface="Segoe UI"/>
                 <a:ea typeface="Microsoft YaHei"/>
               </a:rPr>
-              <a:t>Reactor column specification confirmed for enquiry.  Main-equipment procurement can start from this point — it does not wait for 3D freeze.</a:t>
+              <a:t>Reactor specification confirmed for enquiry.  Main-equipment procurement can then start — it does not wait for 3D freeze.</a:t>
             </a:r>
           </a:p>
           <a:p>
@@ -5479,7 +5440,7 @@
                 <a:latin typeface="Segoe UI"/>
                 <a:ea typeface="Microsoft YaHei"/>
               </a:rPr>
-              <a:t>Sandwich — site walkdown, 3D layout, operating manual, control philosophy and sequence.  Proposed; for confirmation.</a:t>
+              <a:t>Sandwich: walkdown, 3D layout, operating manual, control philosophy and sequence.  Proposed — for confirmation.</a:t>
             </a:r>
           </a:p>
           <a:p>
@@ -5491,7 +5452,7 @@
                 <a:latin typeface="Microsoft YaHei"/>
                 <a:ea typeface="Microsoft YaHei"/>
               </a:rPr>
-              <a:t>赴 Sandwich：现场勘察、3D 布置、操作手册、控制说明与顺控。建议档期，待确认。</a:t>
+              <a:t>赴 Sandwich：现场勘察、3D、操作手册、控制说明与顺控。建议档期，待确认。</a:t>
             </a:r>
           </a:p>
         </p:txBody>
@@ -5665,7 +5626,7 @@
                 <a:latin typeface="Segoe UI"/>
                 <a:ea typeface="Microsoft YaHei"/>
               </a:rPr>
-              <a:t>Sandwich HAZOP on the layout frozen that week.  Proposed; for confirmation with Keith and Claire.</a:t>
+              <a:t>Sandwich HAZOP on the layout frozen that week.  Proposed — Keith and Claire to confirm.</a:t>
             </a:r>
           </a:p>
           <a:p>
@@ -5677,7 +5638,7 @@
                 <a:latin typeface="Microsoft YaHei"/>
                 <a:ea typeface="Microsoft YaHei"/>
               </a:rPr>
-              <a:t>在当周冻结的布置上做 HAZOP。建议档期，待与 Keith、Claire 确认。</a:t>
+              <a:t>在当周冻结的布置上做 HAZOP。建议档期，待 Keith、Claire 确认。</a:t>
             </a:r>
           </a:p>
         </p:txBody>
@@ -5851,7 +5812,7 @@
                 <a:latin typeface="Segoe UI"/>
                 <a:ea typeface="Microsoft YaHei"/>
               </a:rPr>
-              <a:t>Main-equipment enquiry window after the 1–7 October public holiday in China, once the reactor specification is in hand.</a:t>
+              <a:t>Main-equipment enquiry after the 1–7 October holiday in China, once the reactor specification is in hand.</a:t>
             </a:r>
           </a:p>
           <a:p>
@@ -5863,7 +5824,7 @@
                 <a:latin typeface="Microsoft YaHei"/>
                 <a:ea typeface="Microsoft YaHei"/>
               </a:rPr>
-              <a:t>中国 10 月 1–7 日假期之后，反应柱规格到位即可进入主设备询价窗口。</a:t>
+              <a:t>中国 10 月 1–7 日假期之后，规格到位即可进入主设备询价。</a:t>
             </a:r>
           </a:p>
         </p:txBody>
@@ -6037,7 +5998,7 @@
                 <a:latin typeface="Segoe UI"/>
                 <a:ea typeface="Microsoft YaHei"/>
               </a:rPr>
-              <a:t>Vendor information confirmation — after manufacturer selection, not before.  Indicative four-week loop.</a:t>
+              <a:t>Vendor information confirmation — after manufacturer selection, not before.  About four weeks.</a:t>
             </a:r>
           </a:p>
           <a:p>
@@ -7363,7 +7324,7 @@
                 <a:latin typeface="Segoe UI"/>
                 <a:ea typeface="Microsoft YaHei"/>
               </a:rPr>
-              <a:t>Proposed window   </a:t>
+              <a:t>Proposed   </a:t>
             </a:r>
             <a:r>
               <a:rPr sz="1200" b="0" i="0">
@@ -7373,7 +7334,7 @@
                 <a:latin typeface="Segoe UI"/>
                 <a:ea typeface="Microsoft YaHei"/>
               </a:rPr>
-              <a:t>Mon 12 – Fri 16 October  (walkdown / 3D / manuals)     Tue 20 – Thu 22 October  (HAZOP)</a:t>
+              <a:t>12–16 Oct (walkdown / 3D / manuals)   ·   20–22 Oct (HAZOP)</a:t>
             </a:r>
           </a:p>
           <a:p>
@@ -7400,7 +7361,7 @@
                 <a:latin typeface="Segoe UI"/>
                 <a:ea typeface="Microsoft YaHei"/>
               </a:rPr>
-              <a:t>Keith  ·  Li Tao  ·  Fan Shuangshuang  ·  Hu Chaoqun  ·  Meng Dezhi     </a:t>
+              <a:t>Keith · Li Tao · Fan Shuangshuang · Hu Chaoqun · Meng Dezhi</a:t>
             </a:r>
             <a:r>
               <a:rPr sz="1100" b="0" i="0">
@@ -7410,7 +7371,7 @@
                 <a:latin typeface="Segoe UI"/>
                 <a:ea typeface="Microsoft YaHei"/>
               </a:rPr>
-              <a:t>Full agenda in  </a:t>
+              <a:t>    Agenda: </a:t>
             </a:r>
             <a:r>
               <a:rPr sz="1100" b="0" i="1">
@@ -7774,7 +7735,7 @@
                 <a:latin typeface="Segoe UI"/>
                 <a:ea typeface="Microsoft YaHei"/>
               </a:rPr>
-              <a:t>Fan — redraw the 3D model to the 8 September direction, and pass the new separator height to process</a:t>
+              <a:t>Fan — redraw the 3D model to the 8 September direction; pass the new separator height to process</a:t>
             </a:r>
           </a:p>
           <a:p>
@@ -7836,7 +7797,7 @@
                 <a:latin typeface="Segoe UI"/>
                 <a:ea typeface="Microsoft YaHei"/>
               </a:rPr>
-              <a:t>Meng — issue the rectangular, reachable cabinet envelope to Keith for enquiry</a:t>
+              <a:t>Meng — send Keith the rectangular, reachable cabinet envelope for enquiry</a:t>
             </a:r>
           </a:p>
           <a:p>
@@ -7853,7 +7814,7 @@
                 <a:latin typeface="Microsoft YaHei"/>
                 <a:ea typeface="Microsoft YaHei"/>
               </a:rPr>
-              <a:t>     孟德智：把“放得下、够得到”的长方形控制柜目标尺寸发给 Keith 询价</a:t>
+              <a:t>     孟德智：把长方形、够得到的控制柜目标尺寸发给 Keith 询价</a:t>
             </a:r>
           </a:p>
         </p:txBody>
@@ -7898,7 +7859,7 @@
                 <a:latin typeface="Segoe UI"/>
                 <a:ea typeface="Microsoft YaHei"/>
               </a:rPr>
-              <a:t>Zhao / Gao — write gasket hardness and PIC-028 (and FCV-004 if needed) FFKM into the datasheets</a:t>
+              <a:t>Zhao / Gao — write gasket hardness and PIC-028 FFKM into the datasheets (FCV-004 if needed)</a:t>
             </a:r>
           </a:p>
           <a:p>
@@ -7915,7 +7876,7 @@
                 <a:latin typeface="Microsoft YaHei"/>
                 <a:ea typeface="Microsoft YaHei"/>
               </a:rPr>
-              <a:t>     赵子亮 / 高宇：垫片硬度与 PIC-028（及必要时 FCV-004）的 FFKM 写入数据单</a:t>
+              <a:t>     赵子亮 / 高宇：垫片硬度与 PIC-028 的 FFKM 写入数据单（必要时含 FCV-004）</a:t>
             </a:r>
           </a:p>
         </p:txBody>
@@ -8022,7 +7983,7 @@
                 <a:latin typeface="Segoe UI"/>
                 <a:ea typeface="Microsoft YaHei"/>
               </a:rPr>
-              <a:t>Raise the main-equipment enquiry once the reactor specification is confirmed — do not hold it for the 3D freeze</a:t>
+              <a:t>Raise the main-equipment enquiry once the reactor specification is confirmed — do not wait for 3D freeze</a:t>
             </a:r>
           </a:p>
           <a:p>
@@ -8084,7 +8045,7 @@
                 <a:latin typeface="Segoe UI"/>
                 <a:ea typeface="Microsoft YaHei"/>
               </a:rPr>
-              <a:t>Confirm the 12–22 October visit window with Keith and Claire, and start visa / travel once the dates are firm</a:t>
+              <a:t>Confirm 12–22 October with Keith and Claire; start visa / travel once the dates are firm</a:t>
             </a:r>
           </a:p>
           <a:p>
@@ -8101,7 +8062,7 @@
                 <a:latin typeface="Microsoft YaHei"/>
                 <a:ea typeface="Microsoft YaHei"/>
               </a:rPr>
-              <a:t>     与 Keith、Claire 确认 10 月 12–22 日行程窗口，日期确定后启动签证与差旅</a:t>
+              <a:t>     与 Keith、Claire 确认 10 月 12–22 日，日期确定后启动签证与差旅</a:t>
             </a:r>
           </a:p>
         </p:txBody>
@@ -8146,7 +8107,7 @@
                 <a:latin typeface="Segoe UI"/>
                 <a:ea typeface="Microsoft YaHei"/>
               </a:rPr>
-              <a:t>Close the remaining tracker lines — cleaning, manuals and control description — at the visit or the next technical session</a:t>
+              <a:t>Close remaining tracker lines — cleaning, manuals, control description — at the visit or the next session</a:t>
             </a:r>
           </a:p>
           <a:p>

</xml_diff>